<commit_message>
Polish enterprise SaaS workflow
</commit_message>
<xml_diff>
--- a/docs/FieldFlow-Voice-Triage-Ayush.pptx
+++ b/docs/FieldFlow-Voice-Triage-Ayush.pptx
@@ -13,9 +13,10 @@
     <p:sldId id="261" r:id="rId7"/>
     <p:sldId id="262" r:id="rId8"/>
     <p:sldId id="263" r:id="rId9"/>
+    <p:sldId id="264" r:id="rId10"/>
   </p:sldIdLst>
   <p:notesMasterIdLst>
-    <p:notesMasterId r:id="rId10"/>
+    <p:notesMasterId r:id="rId11"/>
   </p:notesMasterIdLst>
   <p:sldSz cx="12192000" cy="6858000"/>
   <p:notesSz cx="6858000" cy="12192000"/>
@@ -1149,6 +1150,94 @@
             <a:fld id="{F7021451-1387-4CA6-816F-3879F97B5CBC}" type="slidenum">
               <a:rPr lang="en-US"/>
               <a:t>8</a:t>
+            </a:fld>
+            <a:endParaRPr lang="en-US"/>
+          </a:p>
+        </p:txBody>
+      </p:sp>
+    </p:spTree>
+    <p:extLst>
+      <p:ext uri="{BB962C8B-B14F-4D97-AF65-F5344CB8AC3E}">
+        <p14:creationId xmlns:p14="http://schemas.microsoft.com/office/powerpoint/2010/main" val="1024086991"/>
+      </p:ext>
+    </p:extLst>
+  </p:cSld>
+  <p:clrMapOvr>
+    <a:masterClrMapping/>
+  </p:clrMapOvr>
+</p:notes>
+</file>
+
+<file path=ppt/notesSlides/notesSlide9.xml><?xml version="1.0" encoding="utf-8"?>
+<p:notes xmlns:a="http://schemas.openxmlformats.org/drawingml/2006/main" xmlns:r="http://schemas.openxmlformats.org/officeDocument/2006/relationships" xmlns:p="http://schemas.openxmlformats.org/presentationml/2006/main">
+  <p:cSld>
+    <p:spTree>
+      <p:nvGrpSpPr>
+        <p:cNvPr id="1" name=""/>
+        <p:cNvGrpSpPr/>
+        <p:nvPr/>
+      </p:nvGrpSpPr>
+      <p:grpSpPr>
+        <a:xfrm>
+          <a:off x="0" y="0"/>
+          <a:ext cx="0" cy="0"/>
+          <a:chOff x="0" y="0"/>
+          <a:chExt cx="0" cy="0"/>
+        </a:xfrm>
+      </p:grpSpPr>
+      <p:sp>
+        <p:nvSpPr>
+          <p:cNvPr id="2" name="Slide Image Placeholder 1"/>
+          <p:cNvSpPr>
+            <a:spLocks noGrp="1" noRot="1" noChangeAspect="1"/>
+          </p:cNvSpPr>
+          <p:nvPr>
+            <p:ph type="sldImg"/>
+          </p:nvPr>
+        </p:nvSpPr>
+        <p:spPr/>
+      </p:sp>
+      <p:sp>
+        <p:nvSpPr>
+          <p:cNvPr id="3" name="Notes Placeholder 2"/>
+          <p:cNvSpPr>
+            <a:spLocks noGrp="1"/>
+          </p:cNvSpPr>
+          <p:nvPr>
+            <p:ph type="body" idx="1"/>
+          </p:nvPr>
+        </p:nvSpPr>
+        <p:spPr/>
+        <p:txBody>
+          <a:bodyPr/>
+          <a:lstStyle/>
+          <a:p>
+            <a:r>
+              <a:rPr lang="en-US" dirty="0"/>
+              <a:t/>
+            </a:r>
+            <a:endParaRPr lang="en-US" dirty="0"/>
+          </a:p>
+        </p:txBody>
+      </p:sp>
+      <p:sp>
+        <p:nvSpPr>
+          <p:cNvPr id="4" name="Slide Number Placeholder 3"/>
+          <p:cNvSpPr>
+            <a:spLocks noGrp="1"/>
+          </p:cNvSpPr>
+          <p:nvPr>
+            <p:ph type="sldNum" sz="quarter" idx="10"/>
+          </p:nvPr>
+        </p:nvSpPr>
+        <p:spPr/>
+        <p:txBody>
+          <a:bodyPr/>
+          <a:lstStyle/>
+          <a:p>
+            <a:fld id="{F7021451-1387-4CA6-816F-3879F97B5CBC}" type="slidenum">
+              <a:rPr lang="en-US"/>
+              <a:t>9</a:t>
             </a:fld>
             <a:endParaRPr lang="en-US"/>
           </a:p>
@@ -4713,7 +4802,7 @@
                   <a:srgbClr val="105F4C"/>
                 </a:solidFill>
               </a:rPr>
-              <a:t>3. Detail + action</a:t>
+              <a:t>3. Call evidence</a:t>
             </a:r>
             <a:endParaRPr lang="en-US" sz="1500" dirty="0"/>
           </a:p>
@@ -4751,7 +4840,7 @@
                   <a:srgbClr val="203229"/>
                 </a:solidFill>
               </a:rPr>
-              <a:t>Start Bolna call or demo-safe webhook flow.</a:t>
+              <a:t>Show transcript, extracted impact, site access, and webhook status.</a:t>
             </a:r>
             <a:endParaRPr lang="en-US" sz="1250" dirty="0"/>
           </a:p>
@@ -4827,7 +4916,7 @@
                   <a:srgbClr val="203229"/>
                 </a:solidFill>
               </a:rPr>
-              <a:t>Show priority, SLA, technician skill, likely parts, decision, and timeline.</a:t>
+              <a:t>Show priority, SLA, technician routing, likely parts, decision, and timeline.</a:t>
             </a:r>
             <a:endParaRPr lang="en-US" sz="1250" dirty="0"/>
           </a:p>
@@ -6841,6 +6930,537 @@
                 <a:ea typeface="Aptos Display" pitchFamily="34" charset="-122"/>
                 <a:cs typeface="Aptos Display" pitchFamily="34" charset="-120"/>
               </a:rPr>
+              <a:t>Standout SaaS layer</a:t>
+            </a:r>
+            <a:endParaRPr lang="en-US" sz="2800" dirty="0"/>
+          </a:p>
+        </p:txBody>
+      </p:sp>
+      <p:sp>
+        <p:nvSpPr>
+          <p:cNvPr id="3" name="Text 1"/>
+          <p:cNvSpPr/>
+          <p:nvPr/>
+        </p:nvSpPr>
+        <p:spPr>
+          <a:xfrm>
+            <a:off x="530352" y="1078992"/>
+            <a:ext cx="8046720" cy="384048"/>
+          </a:xfrm>
+          <a:prstGeom prst="rect">
+            <a:avLst/>
+          </a:prstGeom>
+          <a:noFill/>
+          <a:ln/>
+        </p:spPr>
+        <p:txBody>
+          <a:bodyPr wrap="square" lIns="0" tIns="0" rIns="0" bIns="0" rtlCol="0" anchor="ctr">
+            <a:normAutofit/>
+          </a:bodyPr>
+          <a:lstStyle/>
+          <a:p>
+            <a:pPr indent="0" marL="0">
+              <a:buNone/>
+            </a:pPr>
+            <a:r>
+              <a:rPr lang="en-US" sz="1600" dirty="0">
+                <a:solidFill>
+                  <a:srgbClr val="68756C"/>
+                </a:solidFill>
+              </a:rPr>
+              <a:t>The assignment flow is packaged as an enterprise operations console, not a one-off call demo.</a:t>
+            </a:r>
+            <a:endParaRPr lang="en-US" sz="1600" dirty="0"/>
+          </a:p>
+        </p:txBody>
+      </p:sp>
+      <p:sp>
+        <p:nvSpPr>
+          <p:cNvPr id="4" name="Text 2"/>
+          <p:cNvSpPr/>
+          <p:nvPr/>
+        </p:nvSpPr>
+        <p:spPr>
+          <a:xfrm>
+            <a:off x="658368" y="1938528"/>
+            <a:ext cx="3108960" cy="237744"/>
+          </a:xfrm>
+          <a:prstGeom prst="rect">
+            <a:avLst/>
+          </a:prstGeom>
+          <a:noFill/>
+          <a:ln/>
+        </p:spPr>
+        <p:txBody>
+          <a:bodyPr wrap="square" lIns="0" tIns="0" rIns="0" bIns="0" rtlCol="0" anchor="ctr">
+            <a:normAutofit/>
+          </a:bodyPr>
+          <a:lstStyle/>
+          <a:p>
+            <a:pPr indent="0" marL="0">
+              <a:buNone/>
+            </a:pPr>
+            <a:r>
+              <a:rPr lang="en-US" sz="1500" b="1" dirty="0">
+                <a:solidFill>
+                  <a:srgbClr val="105F4C"/>
+                </a:solidFill>
+              </a:rPr>
+              <a:t>Operations brief</a:t>
+            </a:r>
+            <a:endParaRPr lang="en-US" sz="1500" dirty="0"/>
+          </a:p>
+        </p:txBody>
+      </p:sp>
+      <p:sp>
+        <p:nvSpPr>
+          <p:cNvPr id="5" name="Text 3"/>
+          <p:cNvSpPr/>
+          <p:nvPr/>
+        </p:nvSpPr>
+        <p:spPr>
+          <a:xfrm>
+            <a:off x="658368" y="2322576"/>
+            <a:ext cx="4434840" cy="384048"/>
+          </a:xfrm>
+          <a:prstGeom prst="rect">
+            <a:avLst/>
+          </a:prstGeom>
+          <a:noFill/>
+          <a:ln/>
+        </p:spPr>
+        <p:txBody>
+          <a:bodyPr wrap="square" lIns="0" tIns="0" rIns="0" bIns="0" rtlCol="0" anchor="ctr">
+            <a:normAutofit/>
+          </a:bodyPr>
+          <a:lstStyle/>
+          <a:p>
+            <a:pPr indent="0" marL="0">
+              <a:buNone/>
+            </a:pPr>
+            <a:r>
+              <a:rPr lang="en-US" sz="1230" dirty="0">
+                <a:solidFill>
+                  <a:srgbClr val="203229"/>
+                </a:solidFill>
+              </a:rPr>
+              <a:t>Queue health, urgency average, completion rate, and live webhook state.</a:t>
+            </a:r>
+            <a:endParaRPr lang="en-US" sz="1230" dirty="0"/>
+          </a:p>
+        </p:txBody>
+      </p:sp>
+      <p:sp>
+        <p:nvSpPr>
+          <p:cNvPr id="6" name="Text 4"/>
+          <p:cNvSpPr/>
+          <p:nvPr/>
+        </p:nvSpPr>
+        <p:spPr>
+          <a:xfrm>
+            <a:off x="6190488" y="1938528"/>
+            <a:ext cx="3108960" cy="237744"/>
+          </a:xfrm>
+          <a:prstGeom prst="rect">
+            <a:avLst/>
+          </a:prstGeom>
+          <a:noFill/>
+          <a:ln/>
+        </p:spPr>
+        <p:txBody>
+          <a:bodyPr wrap="square" lIns="0" tIns="0" rIns="0" bIns="0" rtlCol="0" anchor="ctr">
+            <a:normAutofit/>
+          </a:bodyPr>
+          <a:lstStyle/>
+          <a:p>
+            <a:pPr indent="0" marL="0">
+              <a:buNone/>
+            </a:pPr>
+            <a:r>
+              <a:rPr lang="en-US" sz="1500" b="1" dirty="0">
+                <a:solidFill>
+                  <a:srgbClr val="105F4C"/>
+                </a:solidFill>
+              </a:rPr>
+              <a:t>Call intelligence</a:t>
+            </a:r>
+            <a:endParaRPr lang="en-US" sz="1500" dirty="0"/>
+          </a:p>
+        </p:txBody>
+      </p:sp>
+      <p:sp>
+        <p:nvSpPr>
+          <p:cNvPr id="7" name="Text 5"/>
+          <p:cNvSpPr/>
+          <p:nvPr/>
+        </p:nvSpPr>
+        <p:spPr>
+          <a:xfrm>
+            <a:off x="6190488" y="2322576"/>
+            <a:ext cx="4434840" cy="384048"/>
+          </a:xfrm>
+          <a:prstGeom prst="rect">
+            <a:avLst/>
+          </a:prstGeom>
+          <a:noFill/>
+          <a:ln/>
+        </p:spPr>
+        <p:txBody>
+          <a:bodyPr wrap="square" lIns="0" tIns="0" rIns="0" bIns="0" rtlCol="0" anchor="ctr">
+            <a:normAutofit/>
+          </a:bodyPr>
+          <a:lstStyle/>
+          <a:p>
+            <a:pPr indent="0" marL="0">
+              <a:buNone/>
+            </a:pPr>
+            <a:r>
+              <a:rPr lang="en-US" sz="1230" dirty="0">
+                <a:solidFill>
+                  <a:srgbClr val="203229"/>
+                </a:solidFill>
+              </a:rPr>
+              <a:t>Transcript plus extracted impact, urgency reason, access, availability, and parts signal.</a:t>
+            </a:r>
+            <a:endParaRPr lang="en-US" sz="1230" dirty="0"/>
+          </a:p>
+        </p:txBody>
+      </p:sp>
+      <p:sp>
+        <p:nvSpPr>
+          <p:cNvPr id="8" name="Text 6"/>
+          <p:cNvSpPr/>
+          <p:nvPr/>
+        </p:nvSpPr>
+        <p:spPr>
+          <a:xfrm>
+            <a:off x="658368" y="3355848"/>
+            <a:ext cx="3108960" cy="237744"/>
+          </a:xfrm>
+          <a:prstGeom prst="rect">
+            <a:avLst/>
+          </a:prstGeom>
+          <a:noFill/>
+          <a:ln/>
+        </p:spPr>
+        <p:txBody>
+          <a:bodyPr wrap="square" lIns="0" tIns="0" rIns="0" bIns="0" rtlCol="0" anchor="ctr">
+            <a:normAutofit/>
+          </a:bodyPr>
+          <a:lstStyle/>
+          <a:p>
+            <a:pPr indent="0" marL="0">
+              <a:buNone/>
+            </a:pPr>
+            <a:r>
+              <a:rPr lang="en-US" sz="1500" b="1" dirty="0">
+                <a:solidFill>
+                  <a:srgbClr val="105F4C"/>
+                </a:solidFill>
+              </a:rPr>
+              <a:t>Routing guidance</a:t>
+            </a:r>
+            <a:endParaRPr lang="en-US" sz="1500" dirty="0"/>
+          </a:p>
+        </p:txBody>
+      </p:sp>
+      <p:sp>
+        <p:nvSpPr>
+          <p:cNvPr id="9" name="Text 7"/>
+          <p:cNvSpPr/>
+          <p:nvPr/>
+        </p:nvSpPr>
+        <p:spPr>
+          <a:xfrm>
+            <a:off x="658368" y="3739896"/>
+            <a:ext cx="4434840" cy="384048"/>
+          </a:xfrm>
+          <a:prstGeom prst="rect">
+            <a:avLst/>
+          </a:prstGeom>
+          <a:noFill/>
+          <a:ln/>
+        </p:spPr>
+        <p:txBody>
+          <a:bodyPr wrap="square" lIns="0" tIns="0" rIns="0" bIns="0" rtlCol="0" anchor="ctr">
+            <a:normAutofit/>
+          </a:bodyPr>
+          <a:lstStyle/>
+          <a:p>
+            <a:pPr indent="0" marL="0">
+              <a:buNone/>
+            </a:pPr>
+            <a:r>
+              <a:rPr lang="en-US" sz="1230" dirty="0">
+                <a:solidFill>
+                  <a:srgbClr val="203229"/>
+                </a:solidFill>
+              </a:rPr>
+              <a:t>Technician skill, SLA, assignment rule, and backend next action.</a:t>
+            </a:r>
+            <a:endParaRPr lang="en-US" sz="1230" dirty="0"/>
+          </a:p>
+        </p:txBody>
+      </p:sp>
+      <p:sp>
+        <p:nvSpPr>
+          <p:cNvPr id="10" name="Text 8"/>
+          <p:cNvSpPr/>
+          <p:nvPr/>
+        </p:nvSpPr>
+        <p:spPr>
+          <a:xfrm>
+            <a:off x="6190488" y="3355848"/>
+            <a:ext cx="3108960" cy="237744"/>
+          </a:xfrm>
+          <a:prstGeom prst="rect">
+            <a:avLst/>
+          </a:prstGeom>
+          <a:noFill/>
+          <a:ln/>
+        </p:spPr>
+        <p:txBody>
+          <a:bodyPr wrap="square" lIns="0" tIns="0" rIns="0" bIns="0" rtlCol="0" anchor="ctr">
+            <a:normAutofit/>
+          </a:bodyPr>
+          <a:lstStyle/>
+          <a:p>
+            <a:pPr indent="0" marL="0">
+              <a:buNone/>
+            </a:pPr>
+            <a:r>
+              <a:rPr lang="en-US" sz="1500" b="1" dirty="0">
+                <a:solidFill>
+                  <a:srgbClr val="105F4C"/>
+                </a:solidFill>
+              </a:rPr>
+              <a:t>Audit trail</a:t>
+            </a:r>
+            <a:endParaRPr lang="en-US" sz="1500" dirty="0"/>
+          </a:p>
+        </p:txBody>
+      </p:sp>
+      <p:sp>
+        <p:nvSpPr>
+          <p:cNvPr id="11" name="Text 9"/>
+          <p:cNvSpPr/>
+          <p:nvPr/>
+        </p:nvSpPr>
+        <p:spPr>
+          <a:xfrm>
+            <a:off x="6190488" y="3739896"/>
+            <a:ext cx="4434840" cy="384048"/>
+          </a:xfrm>
+          <a:prstGeom prst="rect">
+            <a:avLst/>
+          </a:prstGeom>
+          <a:noFill/>
+          <a:ln/>
+        </p:spPr>
+        <p:txBody>
+          <a:bodyPr wrap="square" lIns="0" tIns="0" rIns="0" bIns="0" rtlCol="0" anchor="ctr">
+            <a:normAutofit/>
+          </a:bodyPr>
+          <a:lstStyle/>
+          <a:p>
+            <a:pPr indent="0" marL="0">
+              <a:buNone/>
+            </a:pPr>
+            <a:r>
+              <a:rPr lang="en-US" sz="1230" dirty="0">
+                <a:solidFill>
+                  <a:srgbClr val="203229"/>
+                </a:solidFill>
+              </a:rPr>
+              <a:t>Timestamped request, call, webhook, and work-order events.</a:t>
+            </a:r>
+            <a:endParaRPr lang="en-US" sz="1230" dirty="0"/>
+          </a:p>
+        </p:txBody>
+      </p:sp>
+      <p:sp>
+        <p:nvSpPr>
+          <p:cNvPr id="12" name="Text 10"/>
+          <p:cNvSpPr/>
+          <p:nvPr/>
+        </p:nvSpPr>
+        <p:spPr>
+          <a:xfrm>
+            <a:off x="658368" y="5349240"/>
+            <a:ext cx="8778240" cy="310896"/>
+          </a:xfrm>
+          <a:prstGeom prst="rect">
+            <a:avLst/>
+          </a:prstGeom>
+          <a:noFill/>
+          <a:ln/>
+        </p:spPr>
+        <p:txBody>
+          <a:bodyPr wrap="square" lIns="0" tIns="0" rIns="0" bIns="0" rtlCol="0" anchor="ctr">
+            <a:normAutofit/>
+          </a:bodyPr>
+          <a:lstStyle/>
+          <a:p>
+            <a:pPr indent="0" marL="0">
+              <a:buNone/>
+            </a:pPr>
+            <a:r>
+              <a:rPr lang="en-US" sz="1300" b="1" dirty="0">
+                <a:solidFill>
+                  <a:srgbClr val="203229"/>
+                </a:solidFill>
+              </a:rPr>
+              <a:t>This keeps scope tight while showing product, frontend, backend, and AI workflow judgment.</a:t>
+            </a:r>
+            <a:endParaRPr lang="en-US" sz="1300" dirty="0"/>
+          </a:p>
+        </p:txBody>
+      </p:sp>
+      <p:sp>
+        <p:nvSpPr>
+          <p:cNvPr id="13" name="Text 11"/>
+          <p:cNvSpPr/>
+          <p:nvPr/>
+        </p:nvSpPr>
+        <p:spPr>
+          <a:xfrm>
+            <a:off x="502920" y="6446520"/>
+            <a:ext cx="7132320" cy="164592"/>
+          </a:xfrm>
+          <a:prstGeom prst="rect">
+            <a:avLst/>
+          </a:prstGeom>
+          <a:noFill/>
+          <a:ln/>
+        </p:spPr>
+        <p:txBody>
+          <a:bodyPr wrap="square" lIns="0" tIns="0" rIns="0" bIns="0" rtlCol="0" anchor="ctr"/>
+          <a:lstStyle/>
+          <a:p>
+            <a:pPr indent="0" marL="0">
+              <a:buNone/>
+            </a:pPr>
+            <a:r>
+              <a:rPr lang="en-US" sz="750" dirty="0">
+                <a:solidFill>
+                  <a:srgbClr val="68756C"/>
+                </a:solidFill>
+                <a:latin typeface="Aptos" pitchFamily="34" charset="0"/>
+                <a:ea typeface="Aptos" pitchFamily="34" charset="-122"/>
+                <a:cs typeface="Aptos" pitchFamily="34" charset="-120"/>
+              </a:rPr>
+              <a:t>FieldFlow Voice Triage | Bolna FSE Assignment</a:t>
+            </a:r>
+            <a:endParaRPr lang="en-US" sz="750" dirty="0"/>
+          </a:p>
+        </p:txBody>
+      </p:sp>
+      <p:sp>
+        <p:nvSpPr>
+          <p:cNvPr id="14" name="Text 12"/>
+          <p:cNvSpPr/>
+          <p:nvPr/>
+        </p:nvSpPr>
+        <p:spPr>
+          <a:xfrm>
+            <a:off x="11201400" y="6364224"/>
+            <a:ext cx="502920" cy="256032"/>
+          </a:xfrm>
+          <a:prstGeom prst="rect">
+            <a:avLst/>
+          </a:prstGeom>
+          <a:noFill/>
+          <a:ln/>
+        </p:spPr>
+        <p:txBody>
+          <a:bodyPr wrap="square" lIns="0" tIns="0" rIns="0" bIns="0" rtlCol="0" anchor="ctr"/>
+          <a:lstStyle/>
+          <a:p>
+            <a:pPr algn="r" indent="0" marL="0">
+              <a:buNone/>
+            </a:pPr>
+            <a:r>
+              <a:rPr lang="en-US" sz="1000" b="1" dirty="0">
+                <a:solidFill>
+                  <a:srgbClr val="105F4C"/>
+                </a:solidFill>
+                <a:latin typeface="Aptos" pitchFamily="34" charset="0"/>
+                <a:ea typeface="Aptos" pitchFamily="34" charset="-122"/>
+                <a:cs typeface="Aptos" pitchFamily="34" charset="-120"/>
+              </a:rPr>
+              <a:t>08</a:t>
+            </a:r>
+            <a:endParaRPr lang="en-US" sz="1000" dirty="0"/>
+          </a:p>
+        </p:txBody>
+      </p:sp>
+    </p:spTree>
+  </p:cSld>
+  <p:clrMapOvr>
+    <a:masterClrMapping/>
+  </p:clrMapOvr>
+</p:sld>
+</file>
+
+<file path=ppt/slides/slide9.xml><?xml version="1.0" encoding="utf-8"?>
+<p:sld xmlns:a="http://schemas.openxmlformats.org/drawingml/2006/main" xmlns:r="http://schemas.openxmlformats.org/officeDocument/2006/relationships" xmlns:p="http://schemas.openxmlformats.org/presentationml/2006/main">
+  <p:cSld name="Slide 9">
+    <p:bg>
+      <p:bgPr>
+        <a:solidFill>
+          <a:srgbClr val="F6F8F2"/>
+        </a:solidFill>
+      </p:bgPr>
+    </p:bg>
+    <p:spTree>
+      <p:nvGrpSpPr>
+        <p:cNvPr id="1" name=""/>
+        <p:cNvGrpSpPr/>
+        <p:nvPr/>
+      </p:nvGrpSpPr>
+      <p:grpSpPr>
+        <a:xfrm>
+          <a:off x="0" y="0"/>
+          <a:ext cx="0" cy="0"/>
+          <a:chOff x="0" y="0"/>
+          <a:chExt cx="0" cy="0"/>
+        </a:xfrm>
+      </p:grpSpPr>
+      <p:sp>
+        <p:nvSpPr>
+          <p:cNvPr id="2" name="Text 0"/>
+          <p:cNvSpPr/>
+          <p:nvPr/>
+        </p:nvSpPr>
+        <p:spPr>
+          <a:xfrm>
+            <a:off x="502920" y="438912"/>
+            <a:ext cx="6949440" cy="566928"/>
+          </a:xfrm>
+          <a:prstGeom prst="rect">
+            <a:avLst/>
+          </a:prstGeom>
+          <a:noFill/>
+          <a:ln/>
+        </p:spPr>
+        <p:txBody>
+          <a:bodyPr wrap="square" lIns="0" tIns="0" rIns="0" bIns="0" rtlCol="0" anchor="ctr">
+            <a:normAutofit/>
+          </a:bodyPr>
+          <a:lstStyle/>
+          <a:p>
+            <a:pPr indent="0" marL="0">
+              <a:buNone/>
+            </a:pPr>
+            <a:r>
+              <a:rPr lang="en-US" sz="2800" b="1" dirty="0">
+                <a:solidFill>
+                  <a:srgbClr val="13241D"/>
+                </a:solidFill>
+                <a:latin typeface="Aptos Display" pitchFamily="34" charset="0"/>
+                <a:ea typeface="Aptos Display" pitchFamily="34" charset="-122"/>
+                <a:cs typeface="Aptos Display" pitchFamily="34" charset="-120"/>
+              </a:rPr>
               <a:t>Demo flow and links</a:t>
             </a:r>
             <a:endParaRPr lang="en-US" sz="2800" dirty="0"/>
@@ -7735,7 +8355,7 @@
                 <a:ea typeface="Aptos" pitchFamily="34" charset="-122"/>
                 <a:cs typeface="Aptos" pitchFamily="34" charset="-120"/>
               </a:rPr>
-              <a:t>08</a:t>
+              <a:t>09</a:t>
             </a:r>
             <a:endParaRPr lang="en-US" sz="1000" dirty="0"/>
           </a:p>

</xml_diff>

<commit_message>
Clean public project wording
</commit_message>
<xml_diff>
--- a/docs/FieldFlow-Voice-Triage-Ayush.pptx
+++ b/docs/FieldFlow-Voice-Triage-Ayush.pptx
@@ -1746,7 +1746,7 @@
                   <a:srgbClr val="CFE3D8"/>
                 </a:solidFill>
               </a:rPr>
-              <a:t>AI voice-assisted enterprise service qualification using Bolna</a:t>
+              <a:t>Bolna-powered enterprise service qualification</a:t>
             </a:r>
             <a:endParaRPr lang="en-US" sz="1800" dirty="0"/>
           </a:p>
@@ -5611,83 +5611,7 @@
       </p:sp>
       <p:sp>
         <p:nvSpPr>
-          <p:cNvPr id="10" name="Text 8"/>
-          <p:cNvSpPr/>
-          <p:nvPr/>
-        </p:nvSpPr>
-        <p:spPr>
-          <a:xfrm>
-            <a:off x="713232" y="3803904"/>
-            <a:ext cx="2926080" cy="219456"/>
-          </a:xfrm>
-          <a:prstGeom prst="rect">
-            <a:avLst/>
-          </a:prstGeom>
-          <a:noFill/>
-          <a:ln/>
-        </p:spPr>
-        <p:txBody>
-          <a:bodyPr wrap="square" lIns="0" tIns="0" rIns="0" bIns="0" rtlCol="0" anchor="ctr">
-            <a:normAutofit/>
-          </a:bodyPr>
-          <a:lstStyle/>
-          <a:p>
-            <a:pPr indent="0" marL="0">
-              <a:buNone/>
-            </a:pPr>
-            <a:r>
-              <a:rPr lang="en-US" sz="1100" b="1" dirty="0">
-                <a:solidFill>
-                  <a:srgbClr val="105F4C"/>
-                </a:solidFill>
-              </a:rPr>
-              <a:t>POST /api/demo/webhook/:id</a:t>
-            </a:r>
-            <a:endParaRPr lang="en-US" sz="1100" dirty="0"/>
-          </a:p>
-        </p:txBody>
-      </p:sp>
-      <p:sp>
-        <p:nvSpPr>
-          <p:cNvPr id="11" name="Text 9"/>
-          <p:cNvSpPr/>
-          <p:nvPr/>
-        </p:nvSpPr>
-        <p:spPr>
-          <a:xfrm>
-            <a:off x="3794760" y="3803904"/>
-            <a:ext cx="2743200" cy="219456"/>
-          </a:xfrm>
-          <a:prstGeom prst="rect">
-            <a:avLst/>
-          </a:prstGeom>
-          <a:noFill/>
-          <a:ln/>
-        </p:spPr>
-        <p:txBody>
-          <a:bodyPr wrap="square" lIns="0" tIns="0" rIns="0" bIns="0" rtlCol="0" anchor="ctr">
-            <a:normAutofit/>
-          </a:bodyPr>
-          <a:lstStyle/>
-          <a:p>
-            <a:pPr indent="0" marL="0">
-              <a:buNone/>
-            </a:pPr>
-            <a:r>
-              <a:rPr lang="en-US" sz="1100" dirty="0">
-                <a:solidFill>
-                  <a:srgbClr val="13241D"/>
-                </a:solidFill>
-              </a:rPr>
-              <a:t>Demo fallback</a:t>
-            </a:r>
-            <a:endParaRPr lang="en-US" sz="1100" dirty="0"/>
-          </a:p>
-        </p:txBody>
-      </p:sp>
-      <p:sp>
-        <p:nvSpPr>
-          <p:cNvPr id="12" name="Shape 10"/>
+          <p:cNvPr id="10" name="Shape 8"/>
           <p:cNvSpPr/>
           <p:nvPr/>
         </p:nvSpPr>
@@ -5710,7 +5634,7 @@
       </p:sp>
       <p:sp>
         <p:nvSpPr>
-          <p:cNvPr id="13" name="Text 11"/>
+          <p:cNvPr id="11" name="Text 9"/>
           <p:cNvSpPr/>
           <p:nvPr/>
         </p:nvSpPr>
@@ -5751,7 +5675,7 @@
       </p:sp>
       <p:sp>
         <p:nvSpPr>
-          <p:cNvPr id="14" name="Shape 12"/>
+          <p:cNvPr id="12" name="Shape 10"/>
           <p:cNvSpPr/>
           <p:nvPr/>
         </p:nvSpPr>
@@ -5778,7 +5702,7 @@
       </p:sp>
       <p:sp>
         <p:nvSpPr>
-          <p:cNvPr id="15" name="Text 13"/>
+          <p:cNvPr id="13" name="Text 11"/>
           <p:cNvSpPr/>
           <p:nvPr/>
         </p:nvSpPr>
@@ -5819,7 +5743,7 @@
       </p:sp>
       <p:sp>
         <p:nvSpPr>
-          <p:cNvPr id="16" name="Shape 14"/>
+          <p:cNvPr id="14" name="Shape 12"/>
           <p:cNvSpPr/>
           <p:nvPr/>
         </p:nvSpPr>
@@ -5846,7 +5770,7 @@
       </p:sp>
       <p:sp>
         <p:nvSpPr>
-          <p:cNvPr id="17" name="Text 15"/>
+          <p:cNvPr id="15" name="Text 13"/>
           <p:cNvSpPr/>
           <p:nvPr/>
         </p:nvSpPr>
@@ -5887,7 +5811,7 @@
       </p:sp>
       <p:sp>
         <p:nvSpPr>
-          <p:cNvPr id="18" name="Shape 16"/>
+          <p:cNvPr id="16" name="Shape 14"/>
           <p:cNvSpPr/>
           <p:nvPr/>
         </p:nvSpPr>
@@ -5914,7 +5838,7 @@
       </p:sp>
       <p:sp>
         <p:nvSpPr>
-          <p:cNvPr id="19" name="Text 17"/>
+          <p:cNvPr id="17" name="Text 15"/>
           <p:cNvSpPr/>
           <p:nvPr/>
         </p:nvSpPr>
@@ -5955,7 +5879,7 @@
       </p:sp>
       <p:sp>
         <p:nvSpPr>
-          <p:cNvPr id="20" name="Shape 18"/>
+          <p:cNvPr id="18" name="Shape 16"/>
           <p:cNvSpPr/>
           <p:nvPr/>
         </p:nvSpPr>
@@ -5982,7 +5906,7 @@
       </p:sp>
       <p:sp>
         <p:nvSpPr>
-          <p:cNvPr id="21" name="Text 19"/>
+          <p:cNvPr id="19" name="Text 17"/>
           <p:cNvSpPr/>
           <p:nvPr/>
         </p:nvSpPr>
@@ -6023,7 +5947,7 @@
       </p:sp>
       <p:sp>
         <p:nvSpPr>
-          <p:cNvPr id="22" name="Shape 20"/>
+          <p:cNvPr id="20" name="Shape 18"/>
           <p:cNvSpPr/>
           <p:nvPr/>
         </p:nvSpPr>
@@ -6050,7 +5974,7 @@
       </p:sp>
       <p:sp>
         <p:nvSpPr>
-          <p:cNvPr id="23" name="Text 21"/>
+          <p:cNvPr id="21" name="Text 19"/>
           <p:cNvSpPr/>
           <p:nvPr/>
         </p:nvSpPr>
@@ -6091,7 +6015,7 @@
       </p:sp>
       <p:sp>
         <p:nvSpPr>
-          <p:cNvPr id="24" name="Shape 22"/>
+          <p:cNvPr id="22" name="Shape 20"/>
           <p:cNvSpPr/>
           <p:nvPr/>
         </p:nvSpPr>
@@ -6118,7 +6042,7 @@
       </p:sp>
       <p:sp>
         <p:nvSpPr>
-          <p:cNvPr id="25" name="Text 23"/>
+          <p:cNvPr id="23" name="Text 21"/>
           <p:cNvSpPr/>
           <p:nvPr/>
         </p:nvSpPr>
@@ -6159,7 +6083,7 @@
       </p:sp>
       <p:sp>
         <p:nvSpPr>
-          <p:cNvPr id="26" name="Text 24"/>
+          <p:cNvPr id="24" name="Text 22"/>
           <p:cNvSpPr/>
           <p:nvPr/>
         </p:nvSpPr>
@@ -6197,7 +6121,7 @@
       </p:sp>
       <p:sp>
         <p:nvSpPr>
-          <p:cNvPr id="27" name="Text 25"/>
+          <p:cNvPr id="25" name="Text 23"/>
           <p:cNvSpPr/>
           <p:nvPr/>
         </p:nvSpPr>
@@ -6236,7 +6160,7 @@
       </p:sp>
       <p:sp>
         <p:nvSpPr>
-          <p:cNvPr id="28" name="Text 26"/>
+          <p:cNvPr id="26" name="Text 24"/>
           <p:cNvSpPr/>
           <p:nvPr/>
         </p:nvSpPr>
@@ -6968,7 +6892,7 @@
                   <a:srgbClr val="68756C"/>
                 </a:solidFill>
               </a:rPr>
-              <a:t>The assignment flow is packaged as an enterprise operations console, not a one-off call demo.</a:t>
+              <a:t>The call workflow is packaged as an enterprise operations console, not a one-off integration.</a:t>
             </a:r>
             <a:endParaRPr lang="en-US" sz="1600" dirty="0"/>
           </a:p>
@@ -7310,7 +7234,7 @@
                   <a:srgbClr val="203229"/>
                 </a:solidFill>
               </a:rPr>
-              <a:t>This keeps scope tight while showing product, frontend, backend, and AI workflow judgment.</a:t>
+              <a:t>This keeps scope tight while showing product, frontend, backend, and workflow judgment.</a:t>
             </a:r>
             <a:endParaRPr lang="en-US" sz="1300" dirty="0"/>
           </a:p>
@@ -7461,7 +7385,7 @@
                 <a:ea typeface="Aptos Display" pitchFamily="34" charset="-122"/>
                 <a:cs typeface="Aptos Display" pitchFamily="34" charset="-120"/>
               </a:rPr>
-              <a:t>Demo flow and links</a:t>
+              <a:t>Workflow flow and links</a:t>
             </a:r>
             <a:endParaRPr lang="en-US" sz="2800" dirty="0"/>
           </a:p>
@@ -8201,7 +8125,7 @@
                   <a:srgbClr val="105F4C"/>
                 </a:solidFill>
               </a:rPr>
-              <a:t>Local demo</a:t>
+              <a:t>Repository</a:t>
             </a:r>
             <a:endParaRPr lang="en-US" sz="1200" dirty="0"/>
           </a:p>
@@ -8216,7 +8140,7 @@
         <p:spPr>
           <a:xfrm>
             <a:off x="2331720" y="4809744"/>
-            <a:ext cx="4023360" cy="219456"/>
+            <a:ext cx="4846320" cy="219456"/>
           </a:xfrm>
           <a:prstGeom prst="rect">
             <a:avLst/>
@@ -8239,7 +8163,7 @@
                   <a:srgbClr val="13241D"/>
                 </a:solidFill>
               </a:rPr>
-              <a:t>http://localhost:5173?demo=1</a:t>
+              <a:t>https://github.com/Flamki/bolna-fieldflow</a:t>
             </a:r>
             <a:endParaRPr lang="en-US" sz="1200" dirty="0"/>
           </a:p>
@@ -8277,7 +8201,7 @@
                   <a:srgbClr val="203229"/>
                 </a:solidFill>
               </a:rPr>
-              <a:t>Submission evidence: GitHub repo, deployed link, deck, screen recording, and call/demo recording.</a:t>
+              <a:t>Submission evidence: GitHub repo, deployed link, deck, screen recording, and call recording.</a:t>
             </a:r>
             <a:endParaRPr lang="en-US" sz="1300" dirty="0"/>
           </a:p>

</xml_diff>